<commit_message>
Part 2 final: replace duplicate comparison with applications, evidence moved to backup
Co-Authored-By: Claude Opus 5.5 <noreply@anthropic.com>
Claude-Session: https://claude.ai/code/session_01618V9g6j6CnYrhcq2i95Vp
</commit_message>
<xml_diff>
--- a/RoF_review/RoF_Part2_DAS_CRAN.pptx
+++ b/RoF_review/RoF_Part2_DAS_CRAN.pptx
@@ -16,6 +16,7 @@
     <p:sldId xmlns:ns0="http://schemas.openxmlformats.org/officeDocument/2006/relationships" id="261" ns0:id="rId12"/>
     <p:sldId xmlns:ns0="http://schemas.openxmlformats.org/officeDocument/2006/relationships" id="262" ns0:id="rId13"/>
     <p:sldId xmlns:ns0="http://schemas.openxmlformats.org/officeDocument/2006/relationships" id="263" ns0:id="rId14"/>
+    <p:sldId xmlns:ns0="http://schemas.openxmlformats.org/officeDocument/2006/relationships" id="264" ns0:id="rId15"/>
   </p:sldIdLst>
   <p:sldSz cx="12191695" cy="6858000"/>
   <p:notesSz cx="6858000" cy="9144000"/>
@@ -933,7 +934,7 @@
           <a:lstStyle/>
           <a:p>
             <a:r>
-              <a:t>Left: aggregated fiber bandwidth, A-RoF far lower (up to 40-fold in the modeled case). Right: EVM; A-RoF ~8 % meets 64-QAM but not the 3.5 % 256-QAM limit (3GPP TS 38.104); D-RoF meets it. This is the core trade-off of the talk.</a:t>
+              <a:t>Broader view beyond DAS and C-RAN. One sentence per card. Note for experts: commercial 5G fronthaul is mainly digital today; analog RoF fronthaul is at research and trial stage.</a:t>
             </a:r>
           </a:p>
         </p:txBody>
@@ -1099,6 +1100,76 @@
 </file>
 
 <file path=ppt/notesSlides/notesSlide7.xml><?xml version="1.0" encoding="utf-8"?>
+<p:notes xmlns:a="http://schemas.openxmlformats.org/drawingml/2006/main" xmlns:p="http://schemas.openxmlformats.org/presentationml/2006/main" xmlns:r="http://schemas.openxmlformats.org/officeDocument/2006/relationships">
+  <p:cSld>
+    <p:spTree>
+      <p:nvGrpSpPr>
+        <p:cNvPr id="1" name=""/>
+        <p:cNvGrpSpPr/>
+        <p:nvPr/>
+      </p:nvGrpSpPr>
+      <p:grpSpPr>
+        <a:xfrm>
+          <a:off x="0" y="0"/>
+          <a:ext cx="0" cy="0"/>
+          <a:chOff x="0" y="0"/>
+          <a:chExt cx="0" cy="0"/>
+        </a:xfrm>
+      </p:grpSpPr>
+      <p:sp>
+        <p:nvSpPr>
+          <p:cNvPr id="2" name="Slide Image Placeholder 1"/>
+          <p:cNvSpPr>
+            <a:spLocks noGrp="1"/>
+          </p:cNvSpPr>
+          <p:nvPr>
+            <p:ph type="sldImg" idx="2"/>
+          </p:nvPr>
+        </p:nvSpPr>
+        <p:spPr/>
+      </p:sp>
+      <p:sp>
+        <p:nvSpPr>
+          <p:cNvPr id="3" name="Notes Placeholder 2"/>
+          <p:cNvSpPr>
+            <a:spLocks noGrp="1"/>
+          </p:cNvSpPr>
+          <p:nvPr>
+            <p:ph type="body" idx="3" sz="quarter"/>
+          </p:nvPr>
+        </p:nvSpPr>
+        <p:spPr/>
+        <p:txBody>
+          <a:bodyPr/>
+          <a:lstStyle/>
+          <a:p>
+            <a:r>
+              <a:t>Left: aggregated fiber bandwidth, A-RoF far lower (up to 40-fold in the modeled case). Right: EVM; A-RoF ~8 % meets 64-QAM but not the 3.5 % 256-QAM limit (3GPP TS 38.104); D-RoF meets it. This is the core trade-off of the talk.</a:t>
+            </a:r>
+          </a:p>
+        </p:txBody>
+      </p:sp>
+      <p:sp>
+        <p:nvSpPr>
+          <p:cNvPr id="4" name="Slide Number Placeholder 3"/>
+          <p:cNvSpPr>
+            <a:spLocks noGrp="1"/>
+          </p:cNvSpPr>
+          <p:nvPr>
+            <p:ph type="sldNum" idx="5" sz="quarter"/>
+          </p:nvPr>
+        </p:nvSpPr>
+        <p:spPr/>
+      </p:sp>
+    </p:spTree>
+  </p:cSld>
+  <p:clrMapOvr>
+    <a:masterClrMapping/>
+  </p:clrMapOvr>
+</p:notes>
+</file>
+
+<file path=ppt/notesSlides/notesSlide8.xml><?xml version="1.0" encoding="utf-8"?>
 <p:notes xmlns:a="http://schemas.openxmlformats.org/drawingml/2006/main" xmlns:p="http://schemas.openxmlformats.org/presentationml/2006/main" xmlns:r="http://schemas.openxmlformats.org/officeDocument/2006/relationships">
   <p:cSld>
     <p:spTree>
@@ -5229,8 +5300,8 @@
         </p:nvSpPr>
         <p:spPr>
           <a:xfrm>
-            <a:off x="548640" y="4480560"/>
-            <a:ext cx="11064240" cy="1645920"/>
+            <a:off x="548640" y="4343400"/>
+            <a:ext cx="11064240" cy="1920240"/>
           </a:xfrm>
           <a:prstGeom prst="rect">
             <a:avLst/>
@@ -5315,6 +5386,31 @@
                 <a:latin typeface="Arial"/>
               </a:rPr>
               <a:t>fronthaul. CPRI: 1.23 Gb/s for 20 MHz × 1 antenna; ≈ 315 Gb/s for 100 MHz × 64 antennas.</a:t>
+            </a:r>
+          </a:p>
+          <a:p>
+            <a:pPr>
+              <a:spcAft>
+                <a:spcPts val="600"/>
+              </a:spcAft>
+            </a:pPr>
+            <a:r>
+              <a:rPr sz="1600" b="1" i="0">
+                <a:solidFill>
+                  <a:srgbClr val="111111"/>
+                </a:solidFill>
+                <a:latin typeface="Arial"/>
+              </a:rPr>
+              <a:t>Analog RoF option: </a:t>
+            </a:r>
+            <a:r>
+              <a:rPr sz="1600" b="0" i="0">
+                <a:solidFill>
+                  <a:srgbClr val="111111"/>
+                </a:solidFill>
+                <a:latin typeface="Arial"/>
+              </a:rPr>
+              <a:t>up to 40× less fronthaul bandwidth, but EVM ≈ 8 % fails the 3.5 % limit for 256-QAM.</a:t>
             </a:r>
           </a:p>
         </p:txBody>
@@ -5353,7 +5449,7 @@
                 </a:solidFill>
                 <a:latin typeface="Arial"/>
               </a:rPr>
-              <a:t>Source: Li, Xie, El-Hajjar, Hanzo, "Analogue Radio Over Fiber for Next-Generation RAN," arXiv:2111.13851 (2021), Fig. 1. Rates: CPRI Specification V7.0.</a:t>
+              <a:t>Source: Li, Xie, El-Hajjar, Hanzo, "Analogue Radio Over Fiber for Next-Generation RAN," arXiv:2111.13851 (2021), Fig. 1 and Sec. V. Rates: CPRI Specification V7.0. EVM limit: 3GPP TS 38.104.</a:t>
             </a:r>
           </a:p>
         </p:txBody>
@@ -5410,79 +5506,50 @@
                 </a:solidFill>
                 <a:latin typeface="Arial"/>
               </a:rPr>
-              <a:t>Analog vs. Digital Fronthaul: Bandwidth vs. Quality</a:t>
-            </a:r>
-          </a:p>
-        </p:txBody>
-      </p:sp>
-      <p:pic>
-        <p:nvPicPr>
-          <p:cNvPr id="3" name="Picture 2" descr="li2021_fig3_bandwidth.jpg"/>
-          <p:cNvPicPr>
-            <a:picLocks noChangeAspect="1"/>
-          </p:cNvPicPr>
+              <a:t>Where Else Is RoF Used?</a:t>
+            </a:r>
+          </a:p>
+        </p:txBody>
+      </p:sp>
+      <p:sp>
+        <p:nvSpPr>
+          <p:cNvPr id="3" name="Rectangle 2"/>
+          <p:cNvSpPr/>
           <p:nvPr/>
-        </p:nvPicPr>
-        <p:blipFill>
-          <a:blip r:embed="rId3"/>
-          <a:stretch>
-            <a:fillRect/>
-          </a:stretch>
-        </p:blipFill>
+        </p:nvSpPr>
         <p:spPr>
           <a:xfrm>
-            <a:off x="548640" y="1188720"/>
-            <a:ext cx="4206240" cy="3150387"/>
+            <a:off x="548640" y="1325880"/>
+            <a:ext cx="3566160" cy="2011680"/>
           </a:xfrm>
           <a:prstGeom prst="rect">
             <a:avLst/>
           </a:prstGeom>
+          <a:noFill/>
           <a:ln w="9525">
             <a:solidFill>
               <a:srgbClr val="A6A6A6"/>
             </a:solidFill>
           </a:ln>
         </p:spPr>
-      </p:pic>
-      <p:pic>
-        <p:nvPicPr>
-          <p:cNvPr id="4" name="Picture 3" descr="li2021_fig5_evm.jpg"/>
-          <p:cNvPicPr>
-            <a:picLocks noChangeAspect="1"/>
-          </p:cNvPicPr>
+        <p:txBody>
+          <a:bodyPr rtlCol="0" anchor="ctr"/>
+          <a:lstStyle/>
+          <a:p>
+            <a:pPr algn="ctr"/>
+          </a:p>
+        </p:txBody>
+      </p:sp>
+      <p:sp>
+        <p:nvSpPr>
+          <p:cNvPr id="4" name="TextBox 3"/>
+          <p:cNvSpPr txBox="1"/>
           <p:nvPr/>
-        </p:nvPicPr>
-        <p:blipFill>
-          <a:blip r:embed="rId4"/>
-          <a:stretch>
-            <a:fillRect/>
-          </a:stretch>
-        </p:blipFill>
+        </p:nvSpPr>
         <p:spPr>
           <a:xfrm>
-            <a:off x="4937760" y="1188720"/>
-            <a:ext cx="6675120" cy="2305053"/>
-          </a:xfrm>
-          <a:prstGeom prst="rect">
-            <a:avLst/>
-          </a:prstGeom>
-          <a:ln w="9525">
-            <a:solidFill>
-              <a:srgbClr val="A6A6A6"/>
-            </a:solidFill>
-          </a:ln>
-        </p:spPr>
-      </p:pic>
-      <p:sp>
-        <p:nvSpPr>
-          <p:cNvPr id="5" name="TextBox 4"/>
-          <p:cNvSpPr txBox="1"/>
-          <p:nvPr/>
-        </p:nvSpPr>
-        <p:spPr>
-          <a:xfrm>
-            <a:off x="548640" y="4572000"/>
-            <a:ext cx="11064240" cy="1554480"/>
+            <a:off x="658368" y="1417320"/>
+            <a:ext cx="3346704" cy="1828800"/>
           </a:xfrm>
           <a:prstGeom prst="rect">
             <a:avLst/>
@@ -5497,58 +5564,376 @@
           <a:p>
             <a:pPr>
               <a:spcAft>
-                <a:spcPts val="600"/>
+                <a:spcPts val="800"/>
               </a:spcAft>
             </a:pPr>
             <a:r>
-              <a:rPr sz="1600" b="1" i="0">
+              <a:rPr sz="1700" b="1" i="0">
                 <a:solidFill>
                   <a:srgbClr val="111111"/>
                 </a:solidFill>
                 <a:latin typeface="Arial"/>
               </a:rPr>
-              <a:t>Analog RoF: </a:t>
-            </a:r>
-            <a:r>
-              <a:rPr sz="1600" b="0" i="0">
-                <a:solidFill>
-                  <a:srgbClr val="111111"/>
-                </a:solidFill>
-                <a:latin typeface="Arial"/>
-              </a:rPr>
-              <a:t>up to 40× less fiber bandwidth, simpler radio head, but EVM ≈ 8 % (fails the 3.5 % limit for 256-QAM).</a:t>
+              <a:t>Venues &amp; transport</a:t>
             </a:r>
           </a:p>
           <a:p>
             <a:pPr>
               <a:spcAft>
-                <a:spcPts val="600"/>
+                <a:spcPts val="800"/>
               </a:spcAft>
             </a:pPr>
             <a:r>
-              <a:rPr sz="1600" b="1" i="0">
+              <a:rPr sz="1700" b="0" i="0">
                 <a:solidFill>
                   <a:srgbClr val="111111"/>
                 </a:solidFill>
                 <a:latin typeface="Arial"/>
               </a:rPr>
-              <a:t>Digital fronthaul: </a:t>
-            </a:r>
-            <a:r>
-              <a:rPr sz="1600" b="0" i="0">
+              <a:t>Stadiums, airports, metros and tunnels: multi-operator fiber DAS.</a:t>
+            </a:r>
+          </a:p>
+        </p:txBody>
+      </p:sp>
+      <p:sp>
+        <p:nvSpPr>
+          <p:cNvPr id="5" name="Rectangle 4"/>
+          <p:cNvSpPr/>
+          <p:nvPr/>
+        </p:nvSpPr>
+        <p:spPr>
+          <a:xfrm>
+            <a:off x="4297679" y="1325880"/>
+            <a:ext cx="3566160" cy="2011680"/>
+          </a:xfrm>
+          <a:prstGeom prst="rect">
+            <a:avLst/>
+          </a:prstGeom>
+          <a:noFill/>
+          <a:ln w="9525">
+            <a:solidFill>
+              <a:srgbClr val="A6A6A6"/>
+            </a:solidFill>
+          </a:ln>
+        </p:spPr>
+        <p:txBody>
+          <a:bodyPr rtlCol="0" anchor="ctr"/>
+          <a:lstStyle/>
+          <a:p>
+            <a:pPr algn="ctr"/>
+          </a:p>
+        </p:txBody>
+      </p:sp>
+      <p:sp>
+        <p:nvSpPr>
+          <p:cNvPr id="6" name="TextBox 5"/>
+          <p:cNvSpPr txBox="1"/>
+          <p:nvPr/>
+        </p:nvSpPr>
+        <p:spPr>
+          <a:xfrm>
+            <a:off x="4407407" y="1417320"/>
+            <a:ext cx="3346704" cy="1828800"/>
+          </a:xfrm>
+          <a:prstGeom prst="rect">
+            <a:avLst/>
+          </a:prstGeom>
+          <a:noFill/>
+        </p:spPr>
+        <p:txBody>
+          <a:bodyPr wrap="square" anchor="t" lIns="45720" rIns="45720">
+            <a:spAutoFit/>
+          </a:bodyPr>
+          <a:lstStyle/>
+          <a:p>
+            <a:pPr>
+              <a:spcAft>
+                <a:spcPts val="800"/>
+              </a:spcAft>
+            </a:pPr>
+            <a:r>
+              <a:rPr sz="1700" b="1" i="0">
                 <a:solidFill>
                   <a:srgbClr val="111111"/>
                 </a:solidFill>
                 <a:latin typeface="Arial"/>
               </a:rPr>
-              <a:t>robust and standardized (CPRI / eCPRI), but bandwidth- and power-hungry.</a:t>
-            </a:r>
-          </a:p>
-        </p:txBody>
-      </p:sp>
-      <p:sp>
-        <p:nvSpPr>
-          <p:cNvPr id="6" name="TextBox 5"/>
+              <a:t>5G / 6G fronthaul</a:t>
+            </a:r>
+          </a:p>
+          <a:p>
+            <a:pPr>
+              <a:spcAft>
+                <a:spcPts val="800"/>
+              </a:spcAft>
+            </a:pPr>
+            <a:r>
+              <a:rPr sz="1700" b="0" i="0">
+                <a:solidFill>
+                  <a:srgbClr val="111111"/>
+                </a:solidFill>
+                <a:latin typeface="Arial"/>
+              </a:rPr>
+              <a:t>Analog RoF studied for mmWave and massive MIMO; commercial fronthaul is mainly digital today.</a:t>
+            </a:r>
+          </a:p>
+        </p:txBody>
+      </p:sp>
+      <p:sp>
+        <p:nvSpPr>
+          <p:cNvPr id="7" name="Rectangle 6"/>
+          <p:cNvSpPr/>
+          <p:nvPr/>
+        </p:nvSpPr>
+        <p:spPr>
+          <a:xfrm>
+            <a:off x="8046719" y="1325880"/>
+            <a:ext cx="3566160" cy="2011680"/>
+          </a:xfrm>
+          <a:prstGeom prst="rect">
+            <a:avLst/>
+          </a:prstGeom>
+          <a:noFill/>
+          <a:ln w="9525">
+            <a:solidFill>
+              <a:srgbClr val="A6A6A6"/>
+            </a:solidFill>
+          </a:ln>
+        </p:spPr>
+        <p:txBody>
+          <a:bodyPr rtlCol="0" anchor="ctr"/>
+          <a:lstStyle/>
+          <a:p>
+            <a:pPr algn="ctr"/>
+          </a:p>
+        </p:txBody>
+      </p:sp>
+      <p:sp>
+        <p:nvSpPr>
+          <p:cNvPr id="8" name="TextBox 7"/>
+          <p:cNvSpPr txBox="1"/>
+          <p:nvPr/>
+        </p:nvSpPr>
+        <p:spPr>
+          <a:xfrm>
+            <a:off x="8156447" y="1417320"/>
+            <a:ext cx="3346704" cy="1828800"/>
+          </a:xfrm>
+          <a:prstGeom prst="rect">
+            <a:avLst/>
+          </a:prstGeom>
+          <a:noFill/>
+        </p:spPr>
+        <p:txBody>
+          <a:bodyPr wrap="square" anchor="t" lIns="45720" rIns="45720">
+            <a:spAutoFit/>
+          </a:bodyPr>
+          <a:lstStyle/>
+          <a:p>
+            <a:pPr>
+              <a:spcAft>
+                <a:spcPts val="800"/>
+              </a:spcAft>
+            </a:pPr>
+            <a:r>
+              <a:rPr sz="1700" b="1" i="0">
+                <a:solidFill>
+                  <a:srgbClr val="111111"/>
+                </a:solidFill>
+                <a:latin typeface="Arial"/>
+              </a:rPr>
+              <a:t>Public safety</a:t>
+            </a:r>
+          </a:p>
+          <a:p>
+            <a:pPr>
+              <a:spcAft>
+                <a:spcPts val="800"/>
+              </a:spcAft>
+            </a:pPr>
+            <a:r>
+              <a:rPr sz="1700" b="0" i="0">
+                <a:solidFill>
+                  <a:srgbClr val="111111"/>
+                </a:solidFill>
+                <a:latin typeface="Arial"/>
+              </a:rPr>
+              <a:t>In-building coverage for emergency-responder radio.</a:t>
+            </a:r>
+          </a:p>
+        </p:txBody>
+      </p:sp>
+      <p:sp>
+        <p:nvSpPr>
+          <p:cNvPr id="9" name="Rectangle 8"/>
+          <p:cNvSpPr/>
+          <p:nvPr/>
+        </p:nvSpPr>
+        <p:spPr>
+          <a:xfrm>
+            <a:off x="2423160" y="3566160"/>
+            <a:ext cx="3566160" cy="2011680"/>
+          </a:xfrm>
+          <a:prstGeom prst="rect">
+            <a:avLst/>
+          </a:prstGeom>
+          <a:noFill/>
+          <a:ln w="9525">
+            <a:solidFill>
+              <a:srgbClr val="A6A6A6"/>
+            </a:solidFill>
+          </a:ln>
+        </p:spPr>
+        <p:txBody>
+          <a:bodyPr rtlCol="0" anchor="ctr"/>
+          <a:lstStyle/>
+          <a:p>
+            <a:pPr algn="ctr"/>
+          </a:p>
+        </p:txBody>
+      </p:sp>
+      <p:sp>
+        <p:nvSpPr>
+          <p:cNvPr id="10" name="TextBox 9"/>
+          <p:cNvSpPr txBox="1"/>
+          <p:nvPr/>
+        </p:nvSpPr>
+        <p:spPr>
+          <a:xfrm>
+            <a:off x="2532888" y="3657600"/>
+            <a:ext cx="3346704" cy="1828800"/>
+          </a:xfrm>
+          <a:prstGeom prst="rect">
+            <a:avLst/>
+          </a:prstGeom>
+          <a:noFill/>
+        </p:spPr>
+        <p:txBody>
+          <a:bodyPr wrap="square" anchor="t" lIns="45720" rIns="45720">
+            <a:spAutoFit/>
+          </a:bodyPr>
+          <a:lstStyle/>
+          <a:p>
+            <a:pPr>
+              <a:spcAft>
+                <a:spcPts val="800"/>
+              </a:spcAft>
+            </a:pPr>
+            <a:r>
+              <a:rPr sz="1700" b="1" i="0">
+                <a:solidFill>
+                  <a:srgbClr val="111111"/>
+                </a:solidFill>
+                <a:latin typeface="Arial"/>
+              </a:rPr>
+              <a:t>Defense &amp; aerospace</a:t>
+            </a:r>
+          </a:p>
+          <a:p>
+            <a:pPr>
+              <a:spcAft>
+                <a:spcPts val="800"/>
+              </a:spcAft>
+            </a:pPr>
+            <a:r>
+              <a:rPr sz="1700" b="0" i="0">
+                <a:solidFill>
+                  <a:srgbClr val="111111"/>
+                </a:solidFill>
+                <a:latin typeface="Arial"/>
+              </a:rPr>
+              <a:t>Antenna remoting, radar and satellite ground stations: light, low-loss, EMI-immune.</a:t>
+            </a:r>
+          </a:p>
+        </p:txBody>
+      </p:sp>
+      <p:sp>
+        <p:nvSpPr>
+          <p:cNvPr id="11" name="Rectangle 10"/>
+          <p:cNvSpPr/>
+          <p:nvPr/>
+        </p:nvSpPr>
+        <p:spPr>
+          <a:xfrm>
+            <a:off x="6172200" y="3566160"/>
+            <a:ext cx="3566160" cy="2011680"/>
+          </a:xfrm>
+          <a:prstGeom prst="rect">
+            <a:avLst/>
+          </a:prstGeom>
+          <a:noFill/>
+          <a:ln w="9525">
+            <a:solidFill>
+              <a:srgbClr val="A6A6A6"/>
+            </a:solidFill>
+          </a:ln>
+        </p:spPr>
+        <p:txBody>
+          <a:bodyPr rtlCol="0" anchor="ctr"/>
+          <a:lstStyle/>
+          <a:p>
+            <a:pPr algn="ctr"/>
+          </a:p>
+        </p:txBody>
+      </p:sp>
+      <p:sp>
+        <p:nvSpPr>
+          <p:cNvPr id="12" name="TextBox 11"/>
+          <p:cNvSpPr txBox="1"/>
+          <p:nvPr/>
+        </p:nvSpPr>
+        <p:spPr>
+          <a:xfrm>
+            <a:off x="6281928" y="3657600"/>
+            <a:ext cx="3346704" cy="1828800"/>
+          </a:xfrm>
+          <a:prstGeom prst="rect">
+            <a:avLst/>
+          </a:prstGeom>
+          <a:noFill/>
+        </p:spPr>
+        <p:txBody>
+          <a:bodyPr wrap="square" anchor="t" lIns="45720" rIns="45720">
+            <a:spAutoFit/>
+          </a:bodyPr>
+          <a:lstStyle/>
+          <a:p>
+            <a:pPr>
+              <a:spcAft>
+                <a:spcPts val="800"/>
+              </a:spcAft>
+            </a:pPr>
+            <a:r>
+              <a:rPr sz="1700" b="1" i="0">
+                <a:solidFill>
+                  <a:srgbClr val="111111"/>
+                </a:solidFill>
+                <a:latin typeface="Arial"/>
+              </a:rPr>
+              <a:t>Radio astronomy</a:t>
+            </a:r>
+          </a:p>
+          <a:p>
+            <a:pPr>
+              <a:spcAft>
+                <a:spcPts val="800"/>
+              </a:spcAft>
+            </a:pPr>
+            <a:r>
+              <a:rPr sz="1700" b="0" i="0">
+                <a:solidFill>
+                  <a:srgbClr val="111111"/>
+                </a:solidFill>
+                <a:latin typeface="Arial"/>
+              </a:rPr>
+              <a:t>RF-over-fiber in the SKA-low radio-telescope receiver.</a:t>
+            </a:r>
+          </a:p>
+        </p:txBody>
+      </p:sp>
+      <p:sp>
+        <p:nvSpPr>
+          <p:cNvPr id="13" name="TextBox 12"/>
           <p:cNvSpPr txBox="1"/>
           <p:nvPr/>
         </p:nvSpPr>
@@ -5580,7 +5965,7 @@
                 </a:solidFill>
                 <a:latin typeface="Arial"/>
               </a:rPr>
-              <a:t>Source: Li, Xie, El-Hajjar, Hanzo, "Analogue Radio Over Fiber for Next-Generation RAN," arXiv:2111.13851 (2021), Figs. 3 and 5. EVM limit: 3GPP TS 38.104.</a:t>
+              <a:t>Sources: ITU-T G.9803 Amd. 2 (2022); Perini et al., J. Astron. Telesc. Instrum. Syst. 8(1), 011016 (2022); NYC subway DAS (Boldyn Networks, 2023).</a:t>
             </a:r>
           </a:p>
         </p:txBody>
@@ -6843,6 +7228,22 @@
               <a:t>6. Times Microwave Systems, LMR-400 datasheet.</a:t>
             </a:r>
           </a:p>
+          <a:p>
+            <a:pPr>
+              <a:spcAft>
+                <a:spcPts val="800"/>
+              </a:spcAft>
+            </a:pPr>
+            <a:r>
+              <a:rPr sz="1600" b="0" i="0">
+                <a:solidFill>
+                  <a:srgbClr val="111111"/>
+                </a:solidFill>
+                <a:latin typeface="Arial"/>
+              </a:rPr>
+              <a:t>7. F. Perini et al., "Radio frequency over fiber technology for SKA-low receiver," JATIS 8(1), 011016, 2022.</a:t>
+            </a:r>
+          </a:p>
         </p:txBody>
       </p:sp>
     </p:spTree>
@@ -6854,6 +7255,233 @@
 </file>
 
 <file path=ppt/slides/slide8.xml><?xml version="1.0" encoding="utf-8"?>
+<p:sld xmlns:a="http://schemas.openxmlformats.org/drawingml/2006/main" xmlns:p="http://schemas.openxmlformats.org/presentationml/2006/main" xmlns:r="http://schemas.openxmlformats.org/officeDocument/2006/relationships">
+  <p:cSld>
+    <p:spTree>
+      <p:nvGrpSpPr>
+        <p:cNvPr id="1" name=""/>
+        <p:cNvGrpSpPr/>
+        <p:nvPr/>
+      </p:nvGrpSpPr>
+      <p:grpSpPr/>
+      <p:sp>
+        <p:nvSpPr>
+          <p:cNvPr id="2" name="TextBox 1"/>
+          <p:cNvSpPr txBox="1"/>
+          <p:nvPr/>
+        </p:nvSpPr>
+        <p:spPr>
+          <a:xfrm>
+            <a:off x="548640" y="320040"/>
+            <a:ext cx="11064240" cy="822960"/>
+          </a:xfrm>
+          <a:prstGeom prst="rect">
+            <a:avLst/>
+          </a:prstGeom>
+          <a:noFill/>
+        </p:spPr>
+        <p:txBody>
+          <a:bodyPr wrap="square" anchor="t" lIns="45720" rIns="45720">
+            <a:spAutoFit/>
+          </a:bodyPr>
+          <a:lstStyle/>
+          <a:p>
+            <a:pPr>
+              <a:spcAft>
+                <a:spcPts val="600"/>
+              </a:spcAft>
+            </a:pPr>
+            <a:r>
+              <a:rPr sz="3400" b="1" i="0">
+                <a:solidFill>
+                  <a:srgbClr val="111111"/>
+                </a:solidFill>
+                <a:latin typeface="Arial"/>
+              </a:rPr>
+              <a:t>Backup: Analog vs. Digital Fronthaul, the Evidence</a:t>
+            </a:r>
+          </a:p>
+        </p:txBody>
+      </p:sp>
+      <p:pic>
+        <p:nvPicPr>
+          <p:cNvPr id="3" name="Picture 2" descr="li2021_fig3_bandwidth.jpg"/>
+          <p:cNvPicPr>
+            <a:picLocks noChangeAspect="1"/>
+          </p:cNvPicPr>
+          <p:nvPr/>
+        </p:nvPicPr>
+        <p:blipFill>
+          <a:blip r:embed="rId3"/>
+          <a:stretch>
+            <a:fillRect/>
+          </a:stretch>
+        </p:blipFill>
+        <p:spPr>
+          <a:xfrm>
+            <a:off x="548640" y="1188720"/>
+            <a:ext cx="4206240" cy="3150387"/>
+          </a:xfrm>
+          <a:prstGeom prst="rect">
+            <a:avLst/>
+          </a:prstGeom>
+          <a:ln w="9525">
+            <a:solidFill>
+              <a:srgbClr val="A6A6A6"/>
+            </a:solidFill>
+          </a:ln>
+        </p:spPr>
+      </p:pic>
+      <p:pic>
+        <p:nvPicPr>
+          <p:cNvPr id="4" name="Picture 3" descr="li2021_fig5_evm.jpg"/>
+          <p:cNvPicPr>
+            <a:picLocks noChangeAspect="1"/>
+          </p:cNvPicPr>
+          <p:nvPr/>
+        </p:nvPicPr>
+        <p:blipFill>
+          <a:blip r:embed="rId4"/>
+          <a:stretch>
+            <a:fillRect/>
+          </a:stretch>
+        </p:blipFill>
+        <p:spPr>
+          <a:xfrm>
+            <a:off x="4937760" y="1188720"/>
+            <a:ext cx="6675120" cy="2305053"/>
+          </a:xfrm>
+          <a:prstGeom prst="rect">
+            <a:avLst/>
+          </a:prstGeom>
+          <a:ln w="9525">
+            <a:solidFill>
+              <a:srgbClr val="A6A6A6"/>
+            </a:solidFill>
+          </a:ln>
+        </p:spPr>
+      </p:pic>
+      <p:sp>
+        <p:nvSpPr>
+          <p:cNvPr id="5" name="TextBox 4"/>
+          <p:cNvSpPr txBox="1"/>
+          <p:nvPr/>
+        </p:nvSpPr>
+        <p:spPr>
+          <a:xfrm>
+            <a:off x="548640" y="4572000"/>
+            <a:ext cx="11064240" cy="1554480"/>
+          </a:xfrm>
+          <a:prstGeom prst="rect">
+            <a:avLst/>
+          </a:prstGeom>
+          <a:noFill/>
+        </p:spPr>
+        <p:txBody>
+          <a:bodyPr wrap="square" anchor="t" lIns="45720" rIns="45720">
+            <a:spAutoFit/>
+          </a:bodyPr>
+          <a:lstStyle/>
+          <a:p>
+            <a:pPr>
+              <a:spcAft>
+                <a:spcPts val="600"/>
+              </a:spcAft>
+            </a:pPr>
+            <a:r>
+              <a:rPr sz="1600" b="1" i="0">
+                <a:solidFill>
+                  <a:srgbClr val="111111"/>
+                </a:solidFill>
+                <a:latin typeface="Arial"/>
+              </a:rPr>
+              <a:t>Analog RoF: </a:t>
+            </a:r>
+            <a:r>
+              <a:rPr sz="1600" b="0" i="0">
+                <a:solidFill>
+                  <a:srgbClr val="111111"/>
+                </a:solidFill>
+                <a:latin typeface="Arial"/>
+              </a:rPr>
+              <a:t>up to 40× less fiber bandwidth, simpler radio head, but EVM ≈ 8 % (fails the 3.5 % limit for 256-QAM).</a:t>
+            </a:r>
+          </a:p>
+          <a:p>
+            <a:pPr>
+              <a:spcAft>
+                <a:spcPts val="600"/>
+              </a:spcAft>
+            </a:pPr>
+            <a:r>
+              <a:rPr sz="1600" b="1" i="0">
+                <a:solidFill>
+                  <a:srgbClr val="111111"/>
+                </a:solidFill>
+                <a:latin typeface="Arial"/>
+              </a:rPr>
+              <a:t>Digital fronthaul: </a:t>
+            </a:r>
+            <a:r>
+              <a:rPr sz="1600" b="0" i="0">
+                <a:solidFill>
+                  <a:srgbClr val="111111"/>
+                </a:solidFill>
+                <a:latin typeface="Arial"/>
+              </a:rPr>
+              <a:t>robust and standardized (CPRI / eCPRI), but bandwidth- and power-hungry.</a:t>
+            </a:r>
+          </a:p>
+        </p:txBody>
+      </p:sp>
+      <p:sp>
+        <p:nvSpPr>
+          <p:cNvPr id="6" name="TextBox 5"/>
+          <p:cNvSpPr txBox="1"/>
+          <p:nvPr/>
+        </p:nvSpPr>
+        <p:spPr>
+          <a:xfrm>
+            <a:off x="548640" y="6309360"/>
+            <a:ext cx="11064240" cy="411480"/>
+          </a:xfrm>
+          <a:prstGeom prst="rect">
+            <a:avLst/>
+          </a:prstGeom>
+          <a:noFill/>
+        </p:spPr>
+        <p:txBody>
+          <a:bodyPr wrap="square" anchor="t" lIns="45720" rIns="45720">
+            <a:spAutoFit/>
+          </a:bodyPr>
+          <a:lstStyle/>
+          <a:p>
+            <a:pPr>
+              <a:spcAft>
+                <a:spcPts val="600"/>
+              </a:spcAft>
+            </a:pPr>
+            <a:r>
+              <a:rPr sz="1100" b="0" i="0">
+                <a:solidFill>
+                  <a:srgbClr val="595959"/>
+                </a:solidFill>
+                <a:latin typeface="Arial"/>
+              </a:rPr>
+              <a:t>Source: Li, Xie, El-Hajjar, Hanzo, "Analogue Radio Over Fiber for Next-Generation RAN," arXiv:2111.13851 (2021), Figs. 3 and 5. EVM limit: 3GPP TS 38.104.</a:t>
+            </a:r>
+          </a:p>
+        </p:txBody>
+      </p:sp>
+    </p:spTree>
+  </p:cSld>
+  <p:clrMapOvr>
+    <a:masterClrMapping/>
+  </p:clrMapOvr>
+</p:sld>
+</file>
+
+<file path=ppt/slides/slide9.xml><?xml version="1.0" encoding="utf-8"?>
 <p:sld xmlns:a="http://schemas.openxmlformats.org/drawingml/2006/main" xmlns:p="http://schemas.openxmlformats.org/presentationml/2006/main" xmlns:r="http://schemas.openxmlformats.org/officeDocument/2006/relationships">
   <p:cSld>
     <p:spTree>

</xml_diff>